<commit_message>
Replay trajectories from disk; verify the shipped bundle; deploy evidence
- /api/traj/load-file: replay a .json trajectory, an episode timeline.csv (using
  the commanded-target columns L_t*/R_t*), or a directory containing one.
  /api/traj/list feeds a per-arm picker in the UI.
- scripts/verify-bundle.sh: extract the zip to a temp dir, run the SHIPPED tests,
  parse every shell script, scan for credentials and real addresses. This caught
  a stale test file that had silently dropped the shaking-bug regression tests.
- docs/deploy-verification.md: actually downloaded one episode of
  HITdongdong/piper_dual_tube (state[14]/action[14], 3 cameras, radians) and read
  the LBST SmolVLA safetensors header via a ranged request
  (state_proj[960,32], action_out_proj[32,720] -> 32-dim padded head).
- Deck: 18 slides, adds file replay and the deployment evidence.
</commit_message>
<xml_diff>
--- a/docs/AgileX-第三轮-操作方式与仿真.pptx
+++ b/docs/AgileX-第三轮-操作方式与仿真.pptx
@@ -9934,6 +9934,27 @@
               <a:t>已有人做到：yuffish/robotwin-pi0_aloha-agilex_clean-50 的 norm_stats 就是 14-in-32。</a:t>
             </a:r>
           </a:p>
+          <a:p>
+            <a:pPr>
+              <a:spcBef>
+                <a:spcPts val="0"/>
+              </a:spcBef>
+              <a:spcAft>
+                <a:spcPts val="0"/>
+              </a:spcAft>
+            </a:pPr>
+            <a:r>
+              <a:rPr sz="1150" b="0">
+                <a:solidFill>
+                  <a:srgbClr val="3FB950"/>
+                </a:solidFill>
+                <a:latin typeface="PingFang SC"/>
+                <a:ea typeface="PingFang SC"/>
+                <a:cs typeface="PingFang SC"/>
+              </a:rPr>
+              <a:t>已实际下载验证：数据集抽 1 条 episode → state[14]/action[14] + 3 相机（弧度）；LBST 权重头部 state_proj[960,32]、action_out_proj[32,720] → 确为 32 维 padding。</a:t>
+            </a:r>
+          </a:p>
         </p:txBody>
       </p:sp>
     </p:spTree>
@@ -13788,8 +13809,8 @@
         </p:nvSpPr>
         <p:spPr>
           <a:xfrm>
-            <a:off x="566928" y="1783080"/>
-            <a:ext cx="5349240" cy="2377440"/>
+            <a:off x="566928" y="1737360"/>
+            <a:ext cx="5349240" cy="2697480"/>
           </a:xfrm>
           <a:prstGeom prst="roundRect">
             <a:avLst>
@@ -13836,8 +13857,8 @@
         </p:nvSpPr>
         <p:spPr>
           <a:xfrm>
-            <a:off x="566928" y="1874520"/>
-            <a:ext cx="41148" cy="2194560"/>
+            <a:off x="566928" y="1828800"/>
+            <a:ext cx="41148" cy="2514600"/>
           </a:xfrm>
           <a:prstGeom prst="rect">
             <a:avLst/>
@@ -13880,7 +13901,7 @@
         </p:nvSpPr>
         <p:spPr>
           <a:xfrm>
-            <a:off x="768096" y="1911096"/>
+            <a:off x="768096" y="1865376"/>
             <a:ext cx="4983480" cy="274320"/>
           </a:xfrm>
           <a:prstGeom prst="rect">
@@ -13924,8 +13945,8 @@
         </p:nvSpPr>
         <p:spPr>
           <a:xfrm>
-            <a:off x="768096" y="2240280"/>
-            <a:ext cx="4983480" cy="1810512"/>
+            <a:off x="768096" y="2194560"/>
+            <a:ext cx="4983480" cy="2130552"/>
           </a:xfrm>
           <a:prstGeom prst="rect">
             <a:avLst/>
@@ -13950,7 +13971,7 @@
               </a:spcAft>
             </a:pPr>
             <a:r>
-              <a:rPr sz="1100" b="0">
+              <a:rPr sz="1050" b="0">
                 <a:solidFill>
                   <a:srgbClr val="E6EDF3"/>
                 </a:solidFill>
@@ -13958,7 +13979,7 @@
                 <a:ea typeface="PingFang SC"/>
                 <a:cs typeface="PingFang SC"/>
               </a:rPr>
-              <a:t>· 6 种操作方式 + 主从开关，已在真机验证</a:t>
+              <a:t>· 6 种操作方式 + 主从开关，真机验证过</a:t>
             </a:r>
           </a:p>
           <a:p>
@@ -13974,7 +13995,7 @@
               </a:spcAft>
             </a:pPr>
             <a:r>
-              <a:rPr sz="1100" b="0">
+              <a:rPr sz="1050" b="0">
                 <a:solidFill>
                   <a:srgbClr val="E6EDF3"/>
                 </a:solidFill>
@@ -13982,7 +14003,7 @@
                 <a:ea typeface="PingFang SC"/>
                 <a:cs typeface="PingFang SC"/>
               </a:rPr>
-              <a:t>· 模式切换改为「以硬件回报为准」</a:t>
+              <a:t>· 模式切换以硬件回报为准</a:t>
             </a:r>
           </a:p>
           <a:p>
@@ -13998,7 +14019,7 @@
               </a:spcAft>
             </a:pPr>
             <a:r>
-              <a:rPr sz="1100" b="0">
+              <a:rPr sz="1050" b="0">
                 <a:solidFill>
                   <a:srgbClr val="E6EDF3"/>
                 </a:solidFill>
@@ -14006,7 +14027,7 @@
                 <a:ea typeface="PingFang SC"/>
                 <a:cs typeface="PingFang SC"/>
               </a:rPr>
-              <a:t>· MOVE P 改为一次性下发，不再与规划器打架</a:t>
+              <a:t>· MOVE P 改一次性下发，不再打架</a:t>
             </a:r>
           </a:p>
           <a:p>
@@ -14022,7 +14043,7 @@
               </a:spcAft>
             </a:pPr>
             <a:r>
-              <a:rPr sz="1100" b="0">
+              <a:rPr sz="1050" b="0">
                 <a:solidFill>
                   <a:srgbClr val="E6EDF3"/>
                 </a:solidFill>
@@ -14046,7 +14067,7 @@
               </a:spcAft>
             </a:pPr>
             <a:r>
-              <a:rPr sz="1100" b="0">
+              <a:rPr sz="1050" b="0">
                 <a:solidFill>
                   <a:srgbClr val="E6EDF3"/>
                 </a:solidFill>
@@ -14070,7 +14091,79 @@
               </a:spcAft>
             </a:pPr>
             <a:r>
-              <a:rPr sz="1100" b="0">
+              <a:rPr sz="1050" b="0">
+                <a:solidFill>
+                  <a:srgbClr val="E6EDF3"/>
+                </a:solidFill>
+                <a:latin typeface="PingFang SC"/>
+                <a:ea typeface="PingFang SC"/>
+                <a:cs typeface="PingFang SC"/>
+              </a:rPr>
+              <a:t>· 轨迹可从文件/目录加载并回放</a:t>
+            </a:r>
+          </a:p>
+          <a:p>
+            <a:pPr>
+              <a:lnSpc>
+                <a:spcPct val="115000"/>
+              </a:lnSpc>
+              <a:spcBef>
+                <a:spcPts val="0"/>
+              </a:spcBef>
+              <a:spcAft>
+                <a:spcPts val="300"/>
+              </a:spcAft>
+            </a:pPr>
+            <a:r>
+              <a:rPr sz="1050" b="0">
+                <a:solidFill>
+                  <a:srgbClr val="E6EDF3"/>
+                </a:solidFill>
+                <a:latin typeface="PingFang SC"/>
+                <a:ea typeface="PingFang SC"/>
+                <a:cs typeface="PingFang SC"/>
+              </a:rPr>
+              <a:t>· 数据集已下载 1 条并核对 schema</a:t>
+            </a:r>
+          </a:p>
+          <a:p>
+            <a:pPr>
+              <a:lnSpc>
+                <a:spcPct val="115000"/>
+              </a:lnSpc>
+              <a:spcBef>
+                <a:spcPts val="0"/>
+              </a:spcBef>
+              <a:spcAft>
+                <a:spcPts val="300"/>
+              </a:spcAft>
+            </a:pPr>
+            <a:r>
+              <a:rPr sz="1050" b="0">
+                <a:solidFill>
+                  <a:srgbClr val="E6EDF3"/>
+                </a:solidFill>
+                <a:latin typeface="PingFang SC"/>
+                <a:ea typeface="PingFang SC"/>
+                <a:cs typeface="PingFang SC"/>
+              </a:rPr>
+              <a:t>· LBST 14 维权重已核对形状</a:t>
+            </a:r>
+          </a:p>
+          <a:p>
+            <a:pPr>
+              <a:lnSpc>
+                <a:spcPct val="115000"/>
+              </a:lnSpc>
+              <a:spcBef>
+                <a:spcPts val="0"/>
+              </a:spcBef>
+              <a:spcAft>
+                <a:spcPts val="300"/>
+              </a:spcAft>
+            </a:pPr>
+            <a:r>
+              <a:rPr sz="1050" b="0">
                 <a:solidFill>
                   <a:srgbClr val="E6EDF3"/>
                 </a:solidFill>
@@ -14091,8 +14184,8 @@
         </p:nvSpPr>
         <p:spPr>
           <a:xfrm>
-            <a:off x="6099048" y="1783080"/>
-            <a:ext cx="5349240" cy="2377440"/>
+            <a:off x="6099048" y="1737360"/>
+            <a:ext cx="5349240" cy="2697480"/>
           </a:xfrm>
           <a:prstGeom prst="roundRect">
             <a:avLst>
@@ -14139,8 +14232,8 @@
         </p:nvSpPr>
         <p:spPr>
           <a:xfrm>
-            <a:off x="6099048" y="1874520"/>
-            <a:ext cx="41148" cy="2194560"/>
+            <a:off x="6099048" y="1828800"/>
+            <a:ext cx="41148" cy="2514600"/>
           </a:xfrm>
           <a:prstGeom prst="rect">
             <a:avLst/>
@@ -14183,7 +14276,7 @@
         </p:nvSpPr>
         <p:spPr>
           <a:xfrm>
-            <a:off x="6300216" y="1911096"/>
+            <a:off x="6300216" y="1865376"/>
             <a:ext cx="4983480" cy="274320"/>
           </a:xfrm>
           <a:prstGeom prst="rect">
@@ -14227,8 +14320,8 @@
         </p:nvSpPr>
         <p:spPr>
           <a:xfrm>
-            <a:off x="6300216" y="2240280"/>
-            <a:ext cx="4983480" cy="1810512"/>
+            <a:off x="6300216" y="2194560"/>
+            <a:ext cx="4983480" cy="2130552"/>
           </a:xfrm>
           <a:prstGeom prst="rect">
             <a:avLst/>
@@ -14370,8 +14463,8 @@
         </p:nvSpPr>
         <p:spPr>
           <a:xfrm>
-            <a:off x="566928" y="4434840"/>
-            <a:ext cx="10881360" cy="1645920"/>
+            <a:off x="566928" y="4617720"/>
+            <a:ext cx="10881360" cy="1554480"/>
           </a:xfrm>
           <a:prstGeom prst="rect">
             <a:avLst/>
@@ -21195,7 +21288,55 @@
                 <a:ea typeface="PingFang SC"/>
                 <a:cs typeface="PingFang SC"/>
               </a:rPr>
-              <a:t>load   给一个 6 角度点的列表 + dt（秒/帧）</a:t>
+              <a:t>load   点列表，或从磁盘读文件 / 目录</a:t>
+            </a:r>
+          </a:p>
+          <a:p>
+            <a:pPr>
+              <a:lnSpc>
+                <a:spcPct val="115000"/>
+              </a:lnSpc>
+              <a:spcBef>
+                <a:spcPts val="0"/>
+              </a:spcBef>
+              <a:spcAft>
+                <a:spcPts val="300"/>
+              </a:spcAft>
+            </a:pPr>
+            <a:r>
+              <a:rPr sz="1200" b="0">
+                <a:solidFill>
+                  <a:srgbClr val="E6EDF3"/>
+                </a:solidFill>
+                <a:latin typeface="PingFang SC"/>
+                <a:ea typeface="PingFang SC"/>
+                <a:cs typeface="PingFang SC"/>
+              </a:rPr>
+              <a:t>       .json 或 episode 的 timeline.csv</a:t>
+            </a:r>
+          </a:p>
+          <a:p>
+            <a:pPr>
+              <a:lnSpc>
+                <a:spcPct val="115000"/>
+              </a:lnSpc>
+              <a:spcBef>
+                <a:spcPts val="0"/>
+              </a:spcBef>
+              <a:spcAft>
+                <a:spcPts val="300"/>
+              </a:spcAft>
+            </a:pPr>
+            <a:r>
+              <a:rPr sz="1200" b="0">
+                <a:solidFill>
+                  <a:srgbClr val="E6EDF3"/>
+                </a:solidFill>
+                <a:latin typeface="PingFang SC"/>
+                <a:ea typeface="PingFang SC"/>
+                <a:cs typeface="PingFang SC"/>
+              </a:rPr>
+              <a:t>       （用目标列 L_t* / R_t*，不是实测列）</a:t>
             </a:r>
           </a:p>
           <a:p>

</xml_diff>